<commit_message>
docs: slide 3 — real in-product outreach thread screenshot replaces the mocked bubbles
Co-Authored-By: Claude Fable 5 <noreply@anthropic.com>
</commit_message>
<xml_diff>
--- a/docs/hackathon/inqi-deck.pptx
+++ b/docs/hackathon/inqi-deck.pptx
@@ -4882,18 +4882,18 @@
         </p:nvSpPr>
         <p:spPr>
           <a:xfrm>
-            <a:off x="640080" y="1691640"/>
-            <a:ext cx="5852160" cy="4480560"/>
+            <a:off x="585216" y="1636776"/>
+            <a:ext cx="5961888" cy="3897399"/>
           </a:xfrm>
           <a:prstGeom prst="roundRect">
             <a:avLst>
-              <a:gd name="adj" fmla="val 2449"/>
+              <a:gd name="adj" fmla="val 1877"/>
             </a:avLst>
           </a:prstGeom>
           <a:solidFill>
-            <a:srgbClr val="FAF9F7"/>
+            <a:srgbClr val="FFFFFF"/>
           </a:solidFill>
-          <a:ln w="12700">
+          <a:ln w="15875">
             <a:solidFill>
               <a:srgbClr val="E4E2DC"/>
             </a:solidFill>
@@ -4901,461 +4901,9 @@
           </a:ln>
         </p:spPr>
       </p:sp>
-      <p:sp>
-        <p:nvSpPr>
-          <p:cNvPr id="5" name="Shape 3"/>
-          <p:cNvSpPr/>
-          <p:nvPr/>
-        </p:nvSpPr>
-        <p:spPr>
-          <a:xfrm>
-            <a:off x="1051560" y="1920240"/>
-            <a:ext cx="5120640" cy="859536"/>
-          </a:xfrm>
-          <a:prstGeom prst="roundRect">
-            <a:avLst>
-              <a:gd name="adj" fmla="val 10638"/>
-            </a:avLst>
-          </a:prstGeom>
-          <a:solidFill>
-            <a:srgbClr val="EAF6EF"/>
-          </a:solidFill>
-          <a:ln w="9525">
-            <a:solidFill>
-              <a:srgbClr val="E4E2DC"/>
-            </a:solidFill>
-            <a:prstDash val="solid"/>
-          </a:ln>
-        </p:spPr>
-      </p:sp>
-      <p:sp>
-        <p:nvSpPr>
-          <p:cNvPr id="6" name="Text 4"/>
-          <p:cNvSpPr/>
-          <p:nvPr/>
-        </p:nvSpPr>
-        <p:spPr>
-          <a:xfrm>
-            <a:off x="1216152" y="1993392"/>
-            <a:ext cx="4791456" cy="219456"/>
-          </a:xfrm>
-          <a:prstGeom prst="rect">
-            <a:avLst/>
-          </a:prstGeom>
-          <a:noFill/>
-          <a:ln/>
-        </p:spPr>
-        <p:txBody>
-          <a:bodyPr wrap="square" lIns="0" tIns="0" rIns="0" bIns="0" rtlCol="0" anchor="ctr"/>
-          <a:lstStyle/>
-          <a:p>
-            <a:pPr indent="0" marL="0">
-              <a:buNone/>
-            </a:pPr>
-            <a:r>
-              <a:rPr lang="en-US" sz="1050" b="1" dirty="0">
-                <a:solidFill>
-                  <a:srgbClr val="0F6F49"/>
-                </a:solidFill>
-                <a:latin typeface="Calibri" pitchFamily="34" charset="0"/>
-                <a:ea typeface="Calibri" pitchFamily="34" charset="-122"/>
-                <a:cs typeface="Calibri" pitchFamily="34" charset="-120"/>
-              </a:rPr>
-              <a:t>inqi (persona: Mariana)</a:t>
-            </a:r>
-            <a:endParaRPr lang="en-US" sz="1050" dirty="0"/>
-          </a:p>
-        </p:txBody>
-      </p:sp>
-      <p:sp>
-        <p:nvSpPr>
-          <p:cNvPr id="7" name="Text 5"/>
-          <p:cNvSpPr/>
-          <p:nvPr/>
-        </p:nvSpPr>
-        <p:spPr>
-          <a:xfrm>
-            <a:off x="1216152" y="2212848"/>
-            <a:ext cx="4791456" cy="512064"/>
-          </a:xfrm>
-          <a:prstGeom prst="rect">
-            <a:avLst/>
-          </a:prstGeom>
-          <a:noFill/>
-          <a:ln/>
-        </p:spPr>
-        <p:txBody>
-          <a:bodyPr wrap="square" lIns="0" tIns="0" rIns="0" bIns="0" rtlCol="0" anchor="ctr"/>
-          <a:lstStyle/>
-          <a:p>
-            <a:pPr indent="0" marL="0">
-              <a:lnSpc>
-                <a:spcPts val="1300"/>
-              </a:lnSpc>
-              <a:buNone/>
-            </a:pPr>
-            <a:r>
-              <a:rPr lang="en-US" sz="1050" dirty="0">
-                <a:solidFill>
-                  <a:srgbClr val="6B6B66"/>
-                </a:solidFill>
-                <a:latin typeface="Calibri" pitchFamily="34" charset="0"/>
-                <a:ea typeface="Calibri" pitchFamily="34" charset="-122"/>
-                <a:cs typeface="Calibri" pitchFamily="34" charset="-120"/>
-              </a:rPr>
-              <a:t>Hi! Looking for grooming for a golden retriever — do you have weekend availability, and what would a full groom cost?</a:t>
-            </a:r>
-            <a:endParaRPr lang="en-US" sz="1050" dirty="0"/>
-          </a:p>
-        </p:txBody>
-      </p:sp>
-      <p:sp>
-        <p:nvSpPr>
-          <p:cNvPr id="8" name="Shape 6"/>
-          <p:cNvSpPr/>
-          <p:nvPr/>
-        </p:nvSpPr>
-        <p:spPr>
-          <a:xfrm>
-            <a:off x="960120" y="2880360"/>
-            <a:ext cx="5120640" cy="859536"/>
-          </a:xfrm>
-          <a:prstGeom prst="roundRect">
-            <a:avLst>
-              <a:gd name="adj" fmla="val 10638"/>
-            </a:avLst>
-          </a:prstGeom>
-          <a:solidFill>
-            <a:srgbClr val="FFFFFF"/>
-          </a:solidFill>
-          <a:ln w="9525">
-            <a:solidFill>
-              <a:srgbClr val="E4E2DC"/>
-            </a:solidFill>
-            <a:prstDash val="solid"/>
-          </a:ln>
-        </p:spPr>
-      </p:sp>
-      <p:sp>
-        <p:nvSpPr>
-          <p:cNvPr id="9" name="Text 7"/>
-          <p:cNvSpPr/>
-          <p:nvPr/>
-        </p:nvSpPr>
-        <p:spPr>
-          <a:xfrm>
-            <a:off x="1124712" y="2953512"/>
-            <a:ext cx="4791456" cy="219456"/>
-          </a:xfrm>
-          <a:prstGeom prst="rect">
-            <a:avLst/>
-          </a:prstGeom>
-          <a:noFill/>
-          <a:ln/>
-        </p:spPr>
-        <p:txBody>
-          <a:bodyPr wrap="square" lIns="0" tIns="0" rIns="0" bIns="0" rtlCol="0" anchor="ctr"/>
-          <a:lstStyle/>
-          <a:p>
-            <a:pPr indent="0" marL="0">
-              <a:buNone/>
-            </a:pPr>
-            <a:r>
-              <a:rPr lang="en-US" sz="1050" b="1" dirty="0">
-                <a:solidFill>
-                  <a:srgbClr val="1C1C1A"/>
-                </a:solidFill>
-                <a:latin typeface="Calibri" pitchFamily="34" charset="0"/>
-                <a:ea typeface="Calibri" pitchFamily="34" charset="-122"/>
-                <a:cs typeface="Calibri" pitchFamily="34" charset="-120"/>
-              </a:rPr>
-              <a:t>Hundesalon (real business)</a:t>
-            </a:r>
-            <a:endParaRPr lang="en-US" sz="1050" dirty="0"/>
-          </a:p>
-        </p:txBody>
-      </p:sp>
-      <p:sp>
-        <p:nvSpPr>
-          <p:cNvPr id="10" name="Text 8"/>
-          <p:cNvSpPr/>
-          <p:nvPr/>
-        </p:nvSpPr>
-        <p:spPr>
-          <a:xfrm>
-            <a:off x="1124712" y="3172968"/>
-            <a:ext cx="4791456" cy="512064"/>
-          </a:xfrm>
-          <a:prstGeom prst="rect">
-            <a:avLst/>
-          </a:prstGeom>
-          <a:noFill/>
-          <a:ln/>
-        </p:spPr>
-        <p:txBody>
-          <a:bodyPr wrap="square" lIns="0" tIns="0" rIns="0" bIns="0" rtlCol="0" anchor="ctr"/>
-          <a:lstStyle/>
-          <a:p>
-            <a:pPr indent="0" marL="0">
-              <a:lnSpc>
-                <a:spcPts val="1300"/>
-              </a:lnSpc>
-              <a:buNone/>
-            </a:pPr>
-            <a:r>
-              <a:rPr lang="en-US" sz="1050" dirty="0">
-                <a:solidFill>
-                  <a:srgbClr val="6B6B66"/>
-                </a:solidFill>
-                <a:latin typeface="Calibri" pitchFamily="34" charset="0"/>
-                <a:ea typeface="Calibri" pitchFamily="34" charset="-122"/>
-                <a:cs typeface="Calibri" pitchFamily="34" charset="-120"/>
-              </a:rPr>
-              <a:t>Yes, we groom large breeds. Saturdays are possible. For a golden retriever a full groom is …</a:t>
-            </a:r>
-            <a:endParaRPr lang="en-US" sz="1050" dirty="0"/>
-          </a:p>
-        </p:txBody>
-      </p:sp>
-      <p:sp>
-        <p:nvSpPr>
-          <p:cNvPr id="11" name="Shape 9"/>
-          <p:cNvSpPr/>
-          <p:nvPr/>
-        </p:nvSpPr>
-        <p:spPr>
-          <a:xfrm>
-            <a:off x="1051560" y="3840480"/>
-            <a:ext cx="5120640" cy="859536"/>
-          </a:xfrm>
-          <a:prstGeom prst="roundRect">
-            <a:avLst>
-              <a:gd name="adj" fmla="val 10638"/>
-            </a:avLst>
-          </a:prstGeom>
-          <a:solidFill>
-            <a:srgbClr val="EAF6EF"/>
-          </a:solidFill>
-          <a:ln w="9525">
-            <a:solidFill>
-              <a:srgbClr val="E4E2DC"/>
-            </a:solidFill>
-            <a:prstDash val="solid"/>
-          </a:ln>
-        </p:spPr>
-      </p:sp>
-      <p:sp>
-        <p:nvSpPr>
-          <p:cNvPr id="12" name="Text 10"/>
-          <p:cNvSpPr/>
-          <p:nvPr/>
-        </p:nvSpPr>
-        <p:spPr>
-          <a:xfrm>
-            <a:off x="1216152" y="3913632"/>
-            <a:ext cx="4791456" cy="219456"/>
-          </a:xfrm>
-          <a:prstGeom prst="rect">
-            <a:avLst/>
-          </a:prstGeom>
-          <a:noFill/>
-          <a:ln/>
-        </p:spPr>
-        <p:txBody>
-          <a:bodyPr wrap="square" lIns="0" tIns="0" rIns="0" bIns="0" rtlCol="0" anchor="ctr"/>
-          <a:lstStyle/>
-          <a:p>
-            <a:pPr indent="0" marL="0">
-              <a:buNone/>
-            </a:pPr>
-            <a:r>
-              <a:rPr lang="en-US" sz="1050" b="1" dirty="0">
-                <a:solidFill>
-                  <a:srgbClr val="0F6F49"/>
-                </a:solidFill>
-                <a:latin typeface="Calibri" pitchFamily="34" charset="0"/>
-                <a:ea typeface="Calibri" pitchFamily="34" charset="-122"/>
-                <a:cs typeface="Calibri" pitchFamily="34" charset="-120"/>
-              </a:rPr>
-              <a:t>inqi</a:t>
-            </a:r>
-            <a:endParaRPr lang="en-US" sz="1050" dirty="0"/>
-          </a:p>
-        </p:txBody>
-      </p:sp>
-      <p:sp>
-        <p:nvSpPr>
-          <p:cNvPr id="13" name="Text 11"/>
-          <p:cNvSpPr/>
-          <p:nvPr/>
-        </p:nvSpPr>
-        <p:spPr>
-          <a:xfrm>
-            <a:off x="1216152" y="4133088"/>
-            <a:ext cx="4791456" cy="512064"/>
-          </a:xfrm>
-          <a:prstGeom prst="rect">
-            <a:avLst/>
-          </a:prstGeom>
-          <a:noFill/>
-          <a:ln/>
-        </p:spPr>
-        <p:txBody>
-          <a:bodyPr wrap="square" lIns="0" tIns="0" rIns="0" bIns="0" rtlCol="0" anchor="ctr"/>
-          <a:lstStyle/>
-          <a:p>
-            <a:pPr indent="0" marL="0">
-              <a:lnSpc>
-                <a:spcPts val="1300"/>
-              </a:lnSpc>
-              <a:buNone/>
-            </a:pPr>
-            <a:r>
-              <a:rPr lang="en-US" sz="1050" dirty="0">
-                <a:solidFill>
-                  <a:srgbClr val="6B6B66"/>
-                </a:solidFill>
-                <a:latin typeface="Calibri" pitchFamily="34" charset="0"/>
-                <a:ea typeface="Calibri" pitchFamily="34" charset="-122"/>
-                <a:cs typeface="Calibri" pitchFamily="34" charset="-120"/>
-              </a:rPr>
-              <a:t>Great — could you confirm the price for a first visit, and how far in advance we should book?</a:t>
-            </a:r>
-            <a:endParaRPr lang="en-US" sz="1050" dirty="0"/>
-          </a:p>
-        </p:txBody>
-      </p:sp>
-      <p:sp>
-        <p:nvSpPr>
-          <p:cNvPr id="14" name="Shape 12"/>
-          <p:cNvSpPr/>
-          <p:nvPr/>
-        </p:nvSpPr>
-        <p:spPr>
-          <a:xfrm>
-            <a:off x="960120" y="4800600"/>
-            <a:ext cx="5120640" cy="859536"/>
-          </a:xfrm>
-          <a:prstGeom prst="roundRect">
-            <a:avLst>
-              <a:gd name="adj" fmla="val 10638"/>
-            </a:avLst>
-          </a:prstGeom>
-          <a:solidFill>
-            <a:srgbClr val="FFFFFF"/>
-          </a:solidFill>
-          <a:ln w="9525">
-            <a:solidFill>
-              <a:srgbClr val="E4E2DC"/>
-            </a:solidFill>
-            <a:prstDash val="solid"/>
-          </a:ln>
-        </p:spPr>
-      </p:sp>
-      <p:sp>
-        <p:nvSpPr>
-          <p:cNvPr id="15" name="Text 13"/>
-          <p:cNvSpPr/>
-          <p:nvPr/>
-        </p:nvSpPr>
-        <p:spPr>
-          <a:xfrm>
-            <a:off x="1124712" y="4873752"/>
-            <a:ext cx="4791456" cy="219456"/>
-          </a:xfrm>
-          <a:prstGeom prst="rect">
-            <a:avLst/>
-          </a:prstGeom>
-          <a:noFill/>
-          <a:ln/>
-        </p:spPr>
-        <p:txBody>
-          <a:bodyPr wrap="square" lIns="0" tIns="0" rIns="0" bIns="0" rtlCol="0" anchor="ctr"/>
-          <a:lstStyle/>
-          <a:p>
-            <a:pPr indent="0" marL="0">
-              <a:buNone/>
-            </a:pPr>
-            <a:r>
-              <a:rPr lang="en-US" sz="1050" b="1" dirty="0">
-                <a:solidFill>
-                  <a:srgbClr val="1C1C1A"/>
-                </a:solidFill>
-                <a:latin typeface="Calibri" pitchFamily="34" charset="0"/>
-                <a:ea typeface="Calibri" pitchFamily="34" charset="-122"/>
-                <a:cs typeface="Calibri" pitchFamily="34" charset="-120"/>
-              </a:rPr>
-              <a:t>Hundesalon</a:t>
-            </a:r>
-            <a:endParaRPr lang="en-US" sz="1050" dirty="0"/>
-          </a:p>
-        </p:txBody>
-      </p:sp>
-      <p:sp>
-        <p:nvSpPr>
-          <p:cNvPr id="16" name="Text 14"/>
-          <p:cNvSpPr/>
-          <p:nvPr/>
-        </p:nvSpPr>
-        <p:spPr>
-          <a:xfrm>
-            <a:off x="1124712" y="5093208"/>
-            <a:ext cx="4791456" cy="512064"/>
-          </a:xfrm>
-          <a:prstGeom prst="rect">
-            <a:avLst/>
-          </a:prstGeom>
-          <a:noFill/>
-          <a:ln/>
-        </p:spPr>
-        <p:txBody>
-          <a:bodyPr wrap="square" lIns="0" tIns="0" rIns="0" bIns="0" rtlCol="0" anchor="ctr"/>
-          <a:lstStyle/>
-          <a:p>
-            <a:pPr indent="0" marL="0">
-              <a:lnSpc>
-                <a:spcPts val="1300"/>
-              </a:lnSpc>
-              <a:buNone/>
-            </a:pPr>
-            <a:r>
-              <a:rPr lang="en-US" sz="1050" dirty="0">
-                <a:solidFill>
-                  <a:srgbClr val="6B6B66"/>
-                </a:solidFill>
-                <a:latin typeface="Calibri" pitchFamily="34" charset="0"/>
-                <a:ea typeface="Calibri" pitchFamily="34" charset="-122"/>
-                <a:cs typeface="Calibri" pitchFamily="34" charset="-120"/>
-              </a:rPr>
-              <a:t>First visit is 20 EUR incl. wash &amp; cut. Booking ~2 weeks ahead is best.</a:t>
-            </a:r>
-            <a:endParaRPr lang="en-US" sz="1050" dirty="0"/>
-          </a:p>
-        </p:txBody>
-      </p:sp>
-      <p:sp>
-        <p:nvSpPr>
-          <p:cNvPr id="17" name="Shape 15"/>
-          <p:cNvSpPr/>
-          <p:nvPr/>
-        </p:nvSpPr>
-        <p:spPr>
-          <a:xfrm>
-            <a:off x="6903720" y="1828800"/>
-            <a:ext cx="457200" cy="457200"/>
-          </a:xfrm>
-          <a:prstGeom prst="ellipse">
-            <a:avLst/>
-          </a:prstGeom>
-          <a:solidFill>
-            <a:srgbClr val="EAF6EF"/>
-          </a:solidFill>
-          <a:ln/>
-        </p:spPr>
-      </p:sp>
       <p:pic>
         <p:nvPicPr>
-          <p:cNvPr id="18" name="Image 0" descr="preencoded.png">    </p:cNvPr>
+          <p:cNvPr id="5" name="Image 0" descr="slide3-thread.png">    </p:cNvPr>
           <p:cNvPicPr>
             <a:picLocks noChangeAspect="1"/>
           </p:cNvPicPr>
@@ -5369,8 +4917,8 @@
         </p:blipFill>
         <p:spPr>
           <a:xfrm>
-            <a:off x="7004304" y="1929384"/>
-            <a:ext cx="256032" cy="256032"/>
+            <a:off x="640080" y="1691640"/>
+            <a:ext cx="5852160" cy="3787671"/>
           </a:xfrm>
           <a:prstGeom prst="rect">
             <a:avLst/>
@@ -5379,53 +4927,14 @@
       </p:pic>
       <p:sp>
         <p:nvSpPr>
-          <p:cNvPr id="19" name="Text 16"/>
-          <p:cNvSpPr/>
-          <p:nvPr/>
-        </p:nvSpPr>
-        <p:spPr>
-          <a:xfrm>
-            <a:off x="7562088" y="1828800"/>
-            <a:ext cx="4023360" cy="292608"/>
-          </a:xfrm>
-          <a:prstGeom prst="rect">
-            <a:avLst/>
-          </a:prstGeom>
-          <a:noFill/>
-          <a:ln/>
-        </p:spPr>
-        <p:txBody>
-          <a:bodyPr wrap="square" lIns="0" tIns="0" rIns="0" bIns="0" rtlCol="0" anchor="ctr"/>
-          <a:lstStyle/>
-          <a:p>
-            <a:pPr indent="0" marL="0">
-              <a:buNone/>
-            </a:pPr>
-            <a:r>
-              <a:rPr lang="en-US" sz="1500" b="1" dirty="0">
-                <a:solidFill>
-                  <a:srgbClr val="1C1C1A"/>
-                </a:solidFill>
-                <a:latin typeface="Calibri" pitchFamily="34" charset="0"/>
-                <a:ea typeface="Calibri" pitchFamily="34" charset="-122"/>
-                <a:cs typeface="Calibri" pitchFamily="34" charset="-120"/>
-              </a:rPr>
-              <a:t>Multi-turn, in character</a:t>
-            </a:r>
-            <a:endParaRPr lang="en-US" sz="1500" dirty="0"/>
-          </a:p>
-        </p:txBody>
-      </p:sp>
-      <p:sp>
-        <p:nvSpPr>
-          <p:cNvPr id="20" name="Text 17"/>
-          <p:cNvSpPr/>
-          <p:nvPr/>
-        </p:nvSpPr>
-        <p:spPr>
-          <a:xfrm>
-            <a:off x="7562088" y="2121408"/>
-            <a:ext cx="4023360" cy="868680"/>
+          <p:cNvPr id="6" name="Text 3"/>
+          <p:cNvSpPr/>
+          <p:nvPr/>
+        </p:nvSpPr>
+        <p:spPr>
+          <a:xfrm>
+            <a:off x="640080" y="5589039"/>
+            <a:ext cx="5852160" cy="365760"/>
           </a:xfrm>
           <a:prstGeom prst="rect">
             <a:avLst/>
@@ -5439,34 +4948,34 @@
           <a:p>
             <a:pPr indent="0" marL="0">
               <a:lnSpc>
-                <a:spcPts val="1500"/>
+                <a:spcPts val="1300"/>
               </a:lnSpc>
               <a:buNone/>
             </a:pPr>
             <a:r>
-              <a:rPr lang="en-US" sz="1200" dirty="0">
-                <a:solidFill>
-                  <a:srgbClr val="6B6B66"/>
-                </a:solidFill>
-                <a:latin typeface="Calibri" pitchFamily="34" charset="0"/>
-                <a:ea typeface="Calibri" pitchFamily="34" charset="-122"/>
-                <a:cs typeface="Calibri" pitchFamily="34" charset="-120"/>
-              </a:rPr>
-              <a:t>Follow-ups handled across the thread; persona held; price confirmed.</a:t>
-            </a:r>
-            <a:endParaRPr lang="en-US" sz="1200" dirty="0"/>
-          </a:p>
-        </p:txBody>
-      </p:sp>
-      <p:sp>
-        <p:nvSpPr>
-          <p:cNvPr id="21" name="Shape 18"/>
-          <p:cNvSpPr/>
-          <p:nvPr/>
-        </p:nvSpPr>
-        <p:spPr>
-          <a:xfrm>
-            <a:off x="6903720" y="3246120"/>
+              <a:rPr lang="en-US" sz="1050" dirty="0">
+                <a:solidFill>
+                  <a:srgbClr val="000000"/>
+                </a:solidFill>
+                <a:latin typeface="Calibri" pitchFamily="34" charset="0"/>
+                <a:ea typeface="Calibri" pitchFamily="34" charset="-122"/>
+                <a:cs typeface="Calibri" pitchFamily="34" charset="-120"/>
+              </a:rPr>
+              <a:t>In-product view: Marlowe (inqi persona) reaches the vendor — the reply routes straight back into the loop.</a:t>
+            </a:r>
+            <a:endParaRPr lang="en-US" sz="1050" dirty="0"/>
+          </a:p>
+        </p:txBody>
+      </p:sp>
+      <p:sp>
+        <p:nvSpPr>
+          <p:cNvPr id="7" name="Shape 4"/>
+          <p:cNvSpPr/>
+          <p:nvPr/>
+        </p:nvSpPr>
+        <p:spPr>
+          <a:xfrm>
+            <a:off x="6903720" y="1828800"/>
             <a:ext cx="457200" cy="457200"/>
           </a:xfrm>
           <a:prstGeom prst="ellipse">
@@ -5480,7 +4989,7 @@
       </p:sp>
       <p:pic>
         <p:nvPicPr>
-          <p:cNvPr id="22" name="Image 1" descr="preencoded.png">    </p:cNvPr>
+          <p:cNvPr id="8" name="Image 1" descr="preencoded.png">    </p:cNvPr>
           <p:cNvPicPr>
             <a:picLocks noChangeAspect="1"/>
           </p:cNvPicPr>
@@ -5494,7 +5003,7 @@
         </p:blipFill>
         <p:spPr>
           <a:xfrm>
-            <a:off x="7004304" y="3346704"/>
+            <a:off x="7004304" y="1929384"/>
             <a:ext cx="256032" cy="256032"/>
           </a:xfrm>
           <a:prstGeom prst="rect">
@@ -5504,13 +5013,13 @@
       </p:pic>
       <p:sp>
         <p:nvSpPr>
-          <p:cNvPr id="23" name="Text 19"/>
-          <p:cNvSpPr/>
-          <p:nvPr/>
-        </p:nvSpPr>
-        <p:spPr>
-          <a:xfrm>
-            <a:off x="7562088" y="3246120"/>
+          <p:cNvPr id="9" name="Text 5"/>
+          <p:cNvSpPr/>
+          <p:nvPr/>
+        </p:nvSpPr>
+        <p:spPr>
+          <a:xfrm>
+            <a:off x="7562088" y="1828800"/>
             <a:ext cx="4023360" cy="292608"/>
           </a:xfrm>
           <a:prstGeom prst="rect">
@@ -5535,7 +5044,7 @@
                 <a:ea typeface="Calibri" pitchFamily="34" charset="-122"/>
                 <a:cs typeface="Calibri" pitchFamily="34" charset="-120"/>
               </a:rPr>
-              <a:t>Safe by construction</a:t>
+              <a:t>Multi-turn, in character</a:t>
             </a:r>
             <a:endParaRPr lang="en-US" sz="1500" dirty="0"/>
           </a:p>
@@ -5543,13 +5052,13 @@
       </p:sp>
       <p:sp>
         <p:nvSpPr>
-          <p:cNvPr id="24" name="Text 20"/>
-          <p:cNvSpPr/>
-          <p:nvPr/>
-        </p:nvSpPr>
-        <p:spPr>
-          <a:xfrm>
-            <a:off x="7562088" y="3538728"/>
+          <p:cNvPr id="10" name="Text 6"/>
+          <p:cNvSpPr/>
+          <p:nvPr/>
+        </p:nvSpPr>
+        <p:spPr>
+          <a:xfrm>
+            <a:off x="7562088" y="2121408"/>
             <a:ext cx="4023360" cy="868680"/>
           </a:xfrm>
           <a:prstGeom prst="rect">
@@ -5577,7 +5086,7 @@
                 <a:ea typeface="Calibri" pitchFamily="34" charset="-122"/>
                 <a:cs typeface="Calibri" pitchFamily="34" charset="-120"/>
               </a:rPr>
-              <a:t>Compliance gates on prompts and inbound replies; outreach pinned during beta so tests never spam real shops.</a:t>
+              <a:t>Follow-ups handled across the thread; persona held; price confirmed.</a:t>
             </a:r>
             <a:endParaRPr lang="en-US" sz="1200" dirty="0"/>
           </a:p>
@@ -5585,13 +5094,13 @@
       </p:sp>
       <p:sp>
         <p:nvSpPr>
-          <p:cNvPr id="25" name="Shape 21"/>
-          <p:cNvSpPr/>
-          <p:nvPr/>
-        </p:nvSpPr>
-        <p:spPr>
-          <a:xfrm>
-            <a:off x="6903720" y="4663440"/>
+          <p:cNvPr id="11" name="Shape 7"/>
+          <p:cNvSpPr/>
+          <p:nvPr/>
+        </p:nvSpPr>
+        <p:spPr>
+          <a:xfrm>
+            <a:off x="6903720" y="3246120"/>
             <a:ext cx="457200" cy="457200"/>
           </a:xfrm>
           <a:prstGeom prst="ellipse">
@@ -5605,7 +5114,7 @@
       </p:sp>
       <p:pic>
         <p:nvPicPr>
-          <p:cNvPr id="26" name="Image 2" descr="preencoded.png">    </p:cNvPr>
+          <p:cNvPr id="12" name="Image 2" descr="preencoded.png">    </p:cNvPr>
           <p:cNvPicPr>
             <a:picLocks noChangeAspect="1"/>
           </p:cNvPicPr>
@@ -5619,6 +5128,131 @@
         </p:blipFill>
         <p:spPr>
           <a:xfrm>
+            <a:off x="7004304" y="3346704"/>
+            <a:ext cx="256032" cy="256032"/>
+          </a:xfrm>
+          <a:prstGeom prst="rect">
+            <a:avLst/>
+          </a:prstGeom>
+        </p:spPr>
+      </p:pic>
+      <p:sp>
+        <p:nvSpPr>
+          <p:cNvPr id="13" name="Text 8"/>
+          <p:cNvSpPr/>
+          <p:nvPr/>
+        </p:nvSpPr>
+        <p:spPr>
+          <a:xfrm>
+            <a:off x="7562088" y="3246120"/>
+            <a:ext cx="4023360" cy="292608"/>
+          </a:xfrm>
+          <a:prstGeom prst="rect">
+            <a:avLst/>
+          </a:prstGeom>
+          <a:noFill/>
+          <a:ln/>
+        </p:spPr>
+        <p:txBody>
+          <a:bodyPr wrap="square" lIns="0" tIns="0" rIns="0" bIns="0" rtlCol="0" anchor="ctr"/>
+          <a:lstStyle/>
+          <a:p>
+            <a:pPr indent="0" marL="0">
+              <a:buNone/>
+            </a:pPr>
+            <a:r>
+              <a:rPr lang="en-US" sz="1500" b="1" dirty="0">
+                <a:solidFill>
+                  <a:srgbClr val="1C1C1A"/>
+                </a:solidFill>
+                <a:latin typeface="Calibri" pitchFamily="34" charset="0"/>
+                <a:ea typeface="Calibri" pitchFamily="34" charset="-122"/>
+                <a:cs typeface="Calibri" pitchFamily="34" charset="-120"/>
+              </a:rPr>
+              <a:t>Safe by construction</a:t>
+            </a:r>
+            <a:endParaRPr lang="en-US" sz="1500" dirty="0"/>
+          </a:p>
+        </p:txBody>
+      </p:sp>
+      <p:sp>
+        <p:nvSpPr>
+          <p:cNvPr id="14" name="Text 9"/>
+          <p:cNvSpPr/>
+          <p:nvPr/>
+        </p:nvSpPr>
+        <p:spPr>
+          <a:xfrm>
+            <a:off x="7562088" y="3538728"/>
+            <a:ext cx="4023360" cy="868680"/>
+          </a:xfrm>
+          <a:prstGeom prst="rect">
+            <a:avLst/>
+          </a:prstGeom>
+          <a:noFill/>
+          <a:ln/>
+        </p:spPr>
+        <p:txBody>
+          <a:bodyPr wrap="square" lIns="0" tIns="0" rIns="0" bIns="0" rtlCol="0" anchor="ctr"/>
+          <a:lstStyle/>
+          <a:p>
+            <a:pPr indent="0" marL="0">
+              <a:lnSpc>
+                <a:spcPts val="1500"/>
+              </a:lnSpc>
+              <a:buNone/>
+            </a:pPr>
+            <a:r>
+              <a:rPr lang="en-US" sz="1200" dirty="0">
+                <a:solidFill>
+                  <a:srgbClr val="6B6B66"/>
+                </a:solidFill>
+                <a:latin typeface="Calibri" pitchFamily="34" charset="0"/>
+                <a:ea typeface="Calibri" pitchFamily="34" charset="-122"/>
+                <a:cs typeface="Calibri" pitchFamily="34" charset="-120"/>
+              </a:rPr>
+              <a:t>Compliance gates on prompts and inbound replies; outreach pinned during beta so tests never spam real shops.</a:t>
+            </a:r>
+            <a:endParaRPr lang="en-US" sz="1200" dirty="0"/>
+          </a:p>
+        </p:txBody>
+      </p:sp>
+      <p:sp>
+        <p:nvSpPr>
+          <p:cNvPr id="15" name="Shape 10"/>
+          <p:cNvSpPr/>
+          <p:nvPr/>
+        </p:nvSpPr>
+        <p:spPr>
+          <a:xfrm>
+            <a:off x="6903720" y="4663440"/>
+            <a:ext cx="457200" cy="457200"/>
+          </a:xfrm>
+          <a:prstGeom prst="ellipse">
+            <a:avLst/>
+          </a:prstGeom>
+          <a:solidFill>
+            <a:srgbClr val="EAF6EF"/>
+          </a:solidFill>
+          <a:ln/>
+        </p:spPr>
+      </p:sp>
+      <p:pic>
+        <p:nvPicPr>
+          <p:cNvPr id="16" name="Image 3" descr="preencoded.png">    </p:cNvPr>
+          <p:cNvPicPr>
+            <a:picLocks noChangeAspect="1"/>
+          </p:cNvPicPr>
+          <p:nvPr/>
+        </p:nvPicPr>
+        <p:blipFill>
+          <a:blip r:embed="rId4"/>
+          <a:stretch>
+            <a:fillRect/>
+          </a:stretch>
+        </p:blipFill>
+        <p:spPr>
+          <a:xfrm>
             <a:off x="7004304" y="4764024"/>
             <a:ext cx="256032" cy="256032"/>
           </a:xfrm>
@@ -5629,7 +5263,7 @@
       </p:pic>
       <p:sp>
         <p:nvSpPr>
-          <p:cNvPr id="27" name="Text 22"/>
+          <p:cNvPr id="17" name="Text 11"/>
           <p:cNvSpPr/>
           <p:nvPr/>
         </p:nvSpPr>
@@ -5668,7 +5302,7 @@
       </p:sp>
       <p:sp>
         <p:nvSpPr>
-          <p:cNvPr id="28" name="Text 23"/>
+          <p:cNvPr id="18" name="Text 12"/>
           <p:cNvSpPr/>
           <p:nvPr/>
         </p:nvSpPr>

</xml_diff>